<commit_message>
Nettoie les traces d'outil des documents suivis par le depot
Cinq documents Office versionnes portaient encore des traces dans leur XML,
alors que les copies livrees avaient ete nettoyees : la source de la
presentation de l'Objectif 3 gardait le theme « ChatGPT » et l'auteur
« Walnut Exporter », et quatre rapports Word portaient « generated by
python-docx » dans leur champ description.

Le depot etant public, ces fichiers y etaient consultables. Les dix documents
suivis sont desormais propres.
</commit_message>
<xml_diff>
--- a/reports/objective3_demonstration/Objectif3_presentation_detaillee.pptx
+++ b/reports/objective3_demonstration/Objectif3_presentation_detaillee.pptx
@@ -264,9 +264,9 @@
 </file>
 
 <file path=ppt/notesMasters/theme/theme3.xml><?xml version="1.0" encoding="utf-8"?>
-<a:theme xmlns:a="http://schemas.openxmlformats.org/drawingml/2006/main" name="ChatGPT">
+<a:theme xmlns:a="http://schemas.openxmlformats.org/drawingml/2006/main" name="McGill WELL-E">
   <a:themeElements>
-    <a:clrScheme name="ChatGPT">
+    <a:clrScheme name="McGill WELL-E">
       <a:dk1>
         <a:srgbClr val="000000"/>
       </a:dk1>
@@ -316,7 +316,7 @@
         <a:cs typeface="Calibri"/>
       </a:minorFont>
     </a:fontScheme>
-    <a:fmtScheme name="ChatGPT">
+    <a:fmtScheme name="McGill WELL-E">
       <a:fillStyleLst>
         <a:solidFill>
           <a:schemeClr val="phClr"/>
@@ -1859,9 +1859,9 @@
 </file>
 
 <file path=ppt/slideMasters/theme/theme2.xml><?xml version="1.0" encoding="utf-8"?>
-<a:theme xmlns:a="http://schemas.openxmlformats.org/drawingml/2006/main" name="ChatGPT">
+<a:theme xmlns:a="http://schemas.openxmlformats.org/drawingml/2006/main" name="McGill WELL-E">
   <a:themeElements>
-    <a:clrScheme name="ChatGPT">
+    <a:clrScheme name="McGill WELL-E">
       <a:dk1>
         <a:srgbClr val="000000"/>
       </a:dk1>
@@ -1911,7 +1911,7 @@
         <a:cs typeface="Calibri"/>
       </a:minorFont>
     </a:fontScheme>
-    <a:fmtScheme name="ChatGPT">
+    <a:fmtScheme name="McGill WELL-E">
       <a:fillStyleLst>
         <a:solidFill>
           <a:schemeClr val="phClr"/>
@@ -12649,9 +12649,9 @@
 </file>
 
 <file path=ppt/theme/theme1.xml><?xml version="1.0" encoding="utf-8"?>
-<a:theme xmlns:a="http://schemas.openxmlformats.org/drawingml/2006/main" name="ChatGPT">
+<a:theme xmlns:a="http://schemas.openxmlformats.org/drawingml/2006/main" name="McGill WELL-E">
   <a:themeElements>
-    <a:clrScheme name="ChatGPT">
+    <a:clrScheme name="McGill WELL-E">
       <a:dk1>
         <a:srgbClr val="000000"/>
       </a:dk1>
@@ -12701,7 +12701,7 @@
         <a:cs typeface="Calibri"/>
       </a:minorFont>
     </a:fontScheme>
-    <a:fmtScheme name="ChatGPT">
+    <a:fmtScheme name="McGill WELL-E">
       <a:fillStyleLst>
         <a:solidFill>
           <a:schemeClr val="phClr"/>

</xml_diff>

<commit_message>
Retire la mention de version de la presentation de l'Objectif 3
La diapositive de titre portait « Version du 2026-07-22 », contraire a la regle
de mise en forme du projet et trompeuse depuis les corrections du 4 aout.
</commit_message>
<xml_diff>
--- a/reports/objective3_demonstration/Objectif3_presentation_detaillee.pptx
+++ b/reports/objective3_demonstration/Objectif3_presentation_detaillee.pptx
@@ -2784,7 +2784,7 @@
                   <a:srgbClr val="475569"/>
                 </a:solidFill>
               </a:rPr>
-              <a:t>Version du 2026-07-22</a:t>
+              <a:t/>
             </a:r>
           </a:p>
         </p:txBody>
@@ -2819,6 +2819,10 @@
             <a:prstDash val="solid"/>
           </a:ln>
         </p:spPr>
+        <p:txBody xmlns:a="http://schemas.openxmlformats.org/drawingml/2006/main">
+          <a:bodyPr/>
+          <a:p/>
+        </p:txBody>
       </p:sp>
       <p:sp>
         <p:nvSpPr>
@@ -3025,6 +3029,10 @@
             <a:prstDash val="solid"/>
           </a:ln>
         </p:spPr>
+        <p:txBody xmlns:a="http://schemas.openxmlformats.org/drawingml/2006/main">
+          <a:bodyPr/>
+          <a:p/>
+        </p:txBody>
       </p:sp>
       <p:sp>
         <p:nvSpPr>
@@ -3550,6 +3558,10 @@
             <a:prstDash val="solid"/>
           </a:ln>
         </p:spPr>
+        <p:txBody xmlns:a="http://schemas.openxmlformats.org/drawingml/2006/main">
+          <a:bodyPr/>
+          <a:p/>
+        </p:txBody>
       </p:sp>
       <p:sp>
         <p:nvSpPr>
@@ -3685,6 +3697,10 @@
             <a:prstDash val="solid"/>
           </a:ln>
         </p:spPr>
+        <p:txBody xmlns:a="http://schemas.openxmlformats.org/drawingml/2006/main">
+          <a:bodyPr/>
+          <a:p/>
+        </p:txBody>
       </p:sp>
       <p:sp>
         <p:nvSpPr>
@@ -3942,6 +3958,10 @@
             <a:prstDash val="solid"/>
           </a:ln>
         </p:spPr>
+        <p:txBody xmlns:a="http://schemas.openxmlformats.org/drawingml/2006/main">
+          <a:bodyPr/>
+          <a:p/>
+        </p:txBody>
       </p:sp>
       <p:sp>
         <p:nvSpPr>
@@ -4077,6 +4097,10 @@
             <a:prstDash val="solid"/>
           </a:ln>
         </p:spPr>
+        <p:txBody xmlns:a="http://schemas.openxmlformats.org/drawingml/2006/main">
+          <a:bodyPr/>
+          <a:p/>
+        </p:txBody>
       </p:sp>
       <p:sp>
         <p:nvSpPr>
@@ -4263,6 +4287,10 @@
             <a:prstDash val="solid"/>
           </a:ln>
         </p:spPr>
+        <p:txBody xmlns:a="http://schemas.openxmlformats.org/drawingml/2006/main">
+          <a:bodyPr/>
+          <a:p/>
+        </p:txBody>
       </p:sp>
       <p:sp>
         <p:nvSpPr>
@@ -4449,6 +4477,10 @@
             <a:prstDash val="solid"/>
           </a:ln>
         </p:spPr>
+        <p:txBody xmlns:a="http://schemas.openxmlformats.org/drawingml/2006/main">
+          <a:bodyPr/>
+          <a:p/>
+        </p:txBody>
       </p:sp>
       <p:sp>
         <p:nvSpPr>
@@ -4635,6 +4667,10 @@
             <a:prstDash val="solid"/>
           </a:ln>
         </p:spPr>
+        <p:txBody xmlns:a="http://schemas.openxmlformats.org/drawingml/2006/main">
+          <a:bodyPr/>
+          <a:p/>
+        </p:txBody>
       </p:sp>
       <p:sp>
         <p:nvSpPr>
@@ -4943,6 +4979,10 @@
             <a:prstDash val="solid"/>
           </a:ln>
         </p:spPr>
+        <p:txBody xmlns:a="http://schemas.openxmlformats.org/drawingml/2006/main">
+          <a:bodyPr/>
+          <a:p/>
+        </p:txBody>
       </p:sp>
       <p:sp>
         <p:nvSpPr>
@@ -5078,6 +5118,10 @@
             <a:prstDash val="solid"/>
           </a:ln>
         </p:spPr>
+        <p:txBody xmlns:a="http://schemas.openxmlformats.org/drawingml/2006/main">
+          <a:bodyPr/>
+          <a:p/>
+        </p:txBody>
       </p:sp>
       <p:sp>
         <p:nvSpPr>
@@ -5614,6 +5658,10 @@
             <a:prstDash val="solid"/>
           </a:ln>
         </p:spPr>
+        <p:txBody xmlns:a="http://schemas.openxmlformats.org/drawingml/2006/main">
+          <a:bodyPr/>
+          <a:p/>
+        </p:txBody>
       </p:sp>
       <p:sp>
         <p:nvSpPr>
@@ -5749,6 +5797,10 @@
             <a:prstDash val="solid"/>
           </a:ln>
         </p:spPr>
+        <p:txBody xmlns:a="http://schemas.openxmlformats.org/drawingml/2006/main">
+          <a:bodyPr/>
+          <a:p/>
+        </p:txBody>
       </p:sp>
       <p:sp>
         <p:nvSpPr>
@@ -5833,6 +5885,10 @@
             <a:prstDash val="solid"/>
           </a:ln>
         </p:spPr>
+        <p:txBody xmlns:a="http://schemas.openxmlformats.org/drawingml/2006/main">
+          <a:bodyPr/>
+          <a:p/>
+        </p:txBody>
       </p:sp>
       <p:sp>
         <p:nvSpPr>
@@ -6019,6 +6075,10 @@
             <a:prstDash val="solid"/>
           </a:ln>
         </p:spPr>
+        <p:txBody xmlns:a="http://schemas.openxmlformats.org/drawingml/2006/main">
+          <a:bodyPr/>
+          <a:p/>
+        </p:txBody>
       </p:sp>
       <p:sp>
         <p:nvSpPr>
@@ -6205,6 +6265,10 @@
             <a:prstDash val="solid"/>
           </a:ln>
         </p:spPr>
+        <p:txBody xmlns:a="http://schemas.openxmlformats.org/drawingml/2006/main">
+          <a:bodyPr/>
+          <a:p/>
+        </p:txBody>
       </p:sp>
       <p:sp>
         <p:nvSpPr>
@@ -6513,6 +6577,10 @@
             <a:prstDash val="solid"/>
           </a:ln>
         </p:spPr>
+        <p:txBody xmlns:a="http://schemas.openxmlformats.org/drawingml/2006/main">
+          <a:bodyPr/>
+          <a:p/>
+        </p:txBody>
       </p:sp>
       <p:sp>
         <p:nvSpPr>
@@ -7241,6 +7309,10 @@
             <a:prstDash val="solid"/>
           </a:ln>
         </p:spPr>
+        <p:txBody xmlns:a="http://schemas.openxmlformats.org/drawingml/2006/main">
+          <a:bodyPr/>
+          <a:p/>
+        </p:txBody>
       </p:sp>
       <p:sp>
         <p:nvSpPr>
@@ -7856,6 +7928,10 @@
             <a:prstDash val="solid"/>
           </a:ln>
         </p:spPr>
+        <p:txBody xmlns:a="http://schemas.openxmlformats.org/drawingml/2006/main">
+          <a:bodyPr/>
+          <a:p/>
+        </p:txBody>
       </p:sp>
       <p:sp>
         <p:nvSpPr>
@@ -8062,6 +8138,10 @@
             <a:prstDash val="solid"/>
           </a:ln>
         </p:spPr>
+        <p:txBody xmlns:a="http://schemas.openxmlformats.org/drawingml/2006/main">
+          <a:bodyPr/>
+          <a:p/>
+        </p:txBody>
       </p:sp>
       <p:sp>
         <p:nvSpPr>
@@ -8197,6 +8277,10 @@
             <a:prstDash val="solid"/>
           </a:ln>
         </p:spPr>
+        <p:txBody xmlns:a="http://schemas.openxmlformats.org/drawingml/2006/main">
+          <a:bodyPr/>
+          <a:p/>
+        </p:txBody>
       </p:sp>
       <p:sp>
         <p:nvSpPr>
@@ -8383,6 +8467,10 @@
             <a:prstDash val="solid"/>
           </a:ln>
         </p:spPr>
+        <p:txBody xmlns:a="http://schemas.openxmlformats.org/drawingml/2006/main">
+          <a:bodyPr/>
+          <a:p/>
+        </p:txBody>
       </p:sp>
       <p:sp>
         <p:nvSpPr>
@@ -8569,6 +8657,10 @@
             <a:prstDash val="solid"/>
           </a:ln>
         </p:spPr>
+        <p:txBody xmlns:a="http://schemas.openxmlformats.org/drawingml/2006/main">
+          <a:bodyPr/>
+          <a:p/>
+        </p:txBody>
       </p:sp>
       <p:sp>
         <p:nvSpPr>
@@ -8755,6 +8847,10 @@
             <a:prstDash val="solid"/>
           </a:ln>
         </p:spPr>
+        <p:txBody xmlns:a="http://schemas.openxmlformats.org/drawingml/2006/main">
+          <a:bodyPr/>
+          <a:p/>
+        </p:txBody>
       </p:sp>
       <p:sp>
         <p:nvSpPr>
@@ -8941,6 +9037,10 @@
             <a:prstDash val="solid"/>
           </a:ln>
         </p:spPr>
+        <p:txBody xmlns:a="http://schemas.openxmlformats.org/drawingml/2006/main">
+          <a:bodyPr/>
+          <a:p/>
+        </p:txBody>
       </p:sp>
       <p:sp>
         <p:nvSpPr>
@@ -9127,6 +9227,10 @@
             <a:prstDash val="solid"/>
           </a:ln>
         </p:spPr>
+        <p:txBody xmlns:a="http://schemas.openxmlformats.org/drawingml/2006/main">
+          <a:bodyPr/>
+          <a:p/>
+        </p:txBody>
       </p:sp>
       <p:sp>
         <p:nvSpPr>
@@ -9486,6 +9590,10 @@
             <a:prstDash val="solid"/>
           </a:ln>
         </p:spPr>
+        <p:txBody xmlns:a="http://schemas.openxmlformats.org/drawingml/2006/main">
+          <a:bodyPr/>
+          <a:p/>
+        </p:txBody>
       </p:sp>
       <p:sp>
         <p:nvSpPr>
@@ -9621,6 +9729,10 @@
             <a:prstDash val="solid"/>
           </a:ln>
         </p:spPr>
+        <p:txBody xmlns:a="http://schemas.openxmlformats.org/drawingml/2006/main">
+          <a:bodyPr/>
+          <a:p/>
+        </p:txBody>
       </p:sp>
       <p:sp>
         <p:nvSpPr>
@@ -9792,6 +9904,10 @@
             <a:prstDash val="solid"/>
           </a:ln>
         </p:spPr>
+        <p:txBody xmlns:a="http://schemas.openxmlformats.org/drawingml/2006/main">
+          <a:bodyPr/>
+          <a:p/>
+        </p:txBody>
       </p:sp>
       <p:sp>
         <p:nvSpPr>
@@ -9963,6 +10079,10 @@
             <a:prstDash val="solid"/>
           </a:ln>
         </p:spPr>
+        <p:txBody xmlns:a="http://schemas.openxmlformats.org/drawingml/2006/main">
+          <a:bodyPr/>
+          <a:p/>
+        </p:txBody>
       </p:sp>
       <p:sp>
         <p:nvSpPr>
@@ -10307,6 +10427,10 @@
             <a:prstDash val="solid"/>
           </a:ln>
         </p:spPr>
+        <p:txBody xmlns:a="http://schemas.openxmlformats.org/drawingml/2006/main">
+          <a:bodyPr/>
+          <a:p/>
+        </p:txBody>
       </p:sp>
       <p:sp>
         <p:nvSpPr>
@@ -10458,6 +10582,10 @@
             <a:prstDash val="solid"/>
           </a:ln>
         </p:spPr>
+        <p:txBody xmlns:a="http://schemas.openxmlformats.org/drawingml/2006/main">
+          <a:bodyPr/>
+          <a:p/>
+        </p:txBody>
       </p:sp>
       <p:sp>
         <p:nvSpPr>
@@ -10644,6 +10772,10 @@
             <a:prstDash val="solid"/>
           </a:ln>
         </p:spPr>
+        <p:txBody xmlns:a="http://schemas.openxmlformats.org/drawingml/2006/main">
+          <a:bodyPr/>
+          <a:p/>
+        </p:txBody>
       </p:sp>
       <p:sp>
         <p:nvSpPr>
@@ -10830,6 +10962,10 @@
             <a:prstDash val="solid"/>
           </a:ln>
         </p:spPr>
+        <p:txBody xmlns:a="http://schemas.openxmlformats.org/drawingml/2006/main">
+          <a:bodyPr/>
+          <a:p/>
+        </p:txBody>
       </p:sp>
       <p:pic>
         <p:nvPicPr>
@@ -11007,6 +11143,10 @@
             <a:prstDash val="solid"/>
           </a:ln>
         </p:spPr>
+        <p:txBody xmlns:a="http://schemas.openxmlformats.org/drawingml/2006/main">
+          <a:bodyPr/>
+          <a:p/>
+        </p:txBody>
       </p:sp>
       <p:sp>
         <p:nvSpPr>
@@ -11142,6 +11282,10 @@
             <a:prstDash val="solid"/>
           </a:ln>
         </p:spPr>
+        <p:txBody xmlns:a="http://schemas.openxmlformats.org/drawingml/2006/main">
+          <a:bodyPr/>
+          <a:p/>
+        </p:txBody>
       </p:sp>
       <p:sp>
         <p:nvSpPr>
@@ -11328,6 +11472,10 @@
             <a:prstDash val="solid"/>
           </a:ln>
         </p:spPr>
+        <p:txBody xmlns:a="http://schemas.openxmlformats.org/drawingml/2006/main">
+          <a:bodyPr/>
+          <a:p/>
+        </p:txBody>
       </p:sp>
       <p:sp>
         <p:nvSpPr>
@@ -11514,6 +11662,10 @@
             <a:prstDash val="solid"/>
           </a:ln>
         </p:spPr>
+        <p:txBody xmlns:a="http://schemas.openxmlformats.org/drawingml/2006/main">
+          <a:bodyPr/>
+          <a:p/>
+        </p:txBody>
       </p:sp>
       <p:sp>
         <p:nvSpPr>
@@ -11700,6 +11852,10 @@
             <a:prstDash val="solid"/>
           </a:ln>
         </p:spPr>
+        <p:txBody xmlns:a="http://schemas.openxmlformats.org/drawingml/2006/main">
+          <a:bodyPr/>
+          <a:p/>
+        </p:txBody>
       </p:sp>
       <p:sp>
         <p:nvSpPr>
@@ -11906,6 +12062,10 @@
             <a:prstDash val="solid"/>
           </a:ln>
         </p:spPr>
+        <p:txBody xmlns:a="http://schemas.openxmlformats.org/drawingml/2006/main">
+          <a:bodyPr/>
+          <a:p/>
+        </p:txBody>
       </p:sp>
       <p:sp>
         <p:nvSpPr>
@@ -12057,6 +12217,10 @@
             <a:prstDash val="solid"/>
           </a:ln>
         </p:spPr>
+        <p:txBody xmlns:a="http://schemas.openxmlformats.org/drawingml/2006/main">
+          <a:bodyPr/>
+          <a:p/>
+        </p:txBody>
       </p:sp>
       <p:sp>
         <p:nvSpPr>
@@ -12243,6 +12407,10 @@
             <a:prstDash val="solid"/>
           </a:ln>
         </p:spPr>
+        <p:txBody xmlns:a="http://schemas.openxmlformats.org/drawingml/2006/main">
+          <a:bodyPr/>
+          <a:p/>
+        </p:txBody>
       </p:sp>
       <p:sp>
         <p:nvSpPr>
@@ -12429,6 +12597,10 @@
             <a:prstDash val="solid"/>
           </a:ln>
         </p:spPr>
+        <p:txBody xmlns:a="http://schemas.openxmlformats.org/drawingml/2006/main">
+          <a:bodyPr/>
+          <a:p/>
+        </p:txBody>
       </p:sp>
       <p:sp>
         <p:nvSpPr>
@@ -12615,6 +12787,10 @@
             <a:prstDash val="solid"/>
           </a:ln>
         </p:spPr>
+        <p:txBody xmlns:a="http://schemas.openxmlformats.org/drawingml/2006/main">
+          <a:bodyPr/>
+          <a:p/>
+        </p:txBody>
       </p:sp>
       <p:pic>
         <p:nvPicPr>

</xml_diff>